<commit_message>
Updates S10 W20 DA
</commit_message>
<xml_diff>
--- a/10-da-toma-decisiones-negocio/20-pruebas-ab.pptx
+++ b/10-da-toma-decisiones-negocio/20-pruebas-ab.pptx
@@ -104,7 +104,7 @@
                 <a:tab algn="l" pos="0"/>
               </a:tabLst>
             </a:pPr>
-            <a:fld id="{73EDB40D-1C5B-467E-8A37-657BF31187F9}" type="slidenum">
+            <a:fld id="{5792D9F5-F34E-47C9-8222-F68110EDC3BA}" type="slidenum">
               <a:rPr b="0" lang="en" sz="1000" strike="noStrike" u="none">
                 <a:solidFill>
                   <a:schemeClr val="dk2"/>
@@ -114,7 +114,7 @@
                 <a:latin typeface="Arial"/>
                 <a:ea typeface="Arial"/>
               </a:rPr>
-              <a:t>&lt;número&gt;</a:t>
+              <a:t>6</a:t>
             </a:fld>
             <a:endParaRPr b="0" lang="es-MX" sz="1000" strike="noStrike" u="none">
               <a:solidFill>
@@ -820,7 +820,7 @@
                 <a:tab algn="l" pos="0"/>
               </a:tabLst>
             </a:pPr>
-            <a:fld id="{452E490D-91C4-4F79-A2B4-BE57FA0F4C24}" type="slidenum">
+            <a:fld id="{97BBEB2C-74C4-47F0-AFC0-694D733A80F6}" type="slidenum">
               <a:rPr b="0" lang="en" sz="1000" strike="noStrike" u="none">
                 <a:solidFill>
                   <a:schemeClr val="dk2"/>
@@ -2084,7 +2084,7 @@
                 <a:tab algn="l" pos="0"/>
               </a:tabLst>
             </a:pPr>
-            <a:fld id="{515B5B86-B747-4E0C-9162-55C55656EC75}" type="slidenum">
+            <a:fld id="{F5DC4EDB-35BE-4629-BEB2-3BF6A66A5D5B}" type="slidenum">
               <a:rPr b="0" lang="en" sz="1000" strike="noStrike" u="none">
                 <a:solidFill>
                   <a:schemeClr val="dk2"/>
@@ -3896,7 +3896,7 @@
                 <a:tab algn="l" pos="0"/>
               </a:tabLst>
             </a:pPr>
-            <a:fld id="{23A7FCE3-82E2-4628-BDD5-F633B8E1B712}" type="slidenum">
+            <a:fld id="{8B9FB406-5899-4822-8507-ECF2169153EA}" type="slidenum">
               <a:rPr b="0" lang="en" sz="1000" strike="noStrike" u="none">
                 <a:solidFill>
                   <a:schemeClr val="dk2"/>
@@ -4005,7 +4005,7 @@
                 <a:tab algn="l" pos="0"/>
               </a:tabLst>
             </a:pPr>
-            <a:fld id="{7913F3D5-EE26-4826-8FB6-7A9A2AB8C838}" type="slidenum">
+            <a:fld id="{8DDBEBDF-5958-4EDA-BF01-37BB5516AA54}" type="slidenum">
               <a:rPr b="0" lang="en" sz="1000" strike="noStrike" u="none">
                 <a:solidFill>
                   <a:schemeClr val="dk2"/>
@@ -4506,7 +4506,7 @@
                 <a:tab algn="l" pos="0"/>
               </a:tabLst>
             </a:pPr>
-            <a:fld id="{B88A5143-F623-4482-A932-39C547FCB87C}" type="slidenum">
+            <a:fld id="{24762ADF-A9E6-49DA-B58F-83B4C97C323D}" type="slidenum">
               <a:rPr b="0" lang="en" sz="1000" strike="noStrike" u="none">
                 <a:solidFill>
                   <a:schemeClr val="dk2"/>
@@ -4948,7 +4948,7 @@
                 <a:tab algn="l" pos="0"/>
               </a:tabLst>
             </a:pPr>
-            <a:fld id="{DD35B214-56B2-4F55-A5AF-EF58AE40E509}" type="slidenum">
+            <a:fld id="{A1529E81-7411-4E69-BA0F-BF79684BFB6F}" type="slidenum">
               <a:rPr b="0" lang="en" sz="1000" strike="noStrike" u="none">
                 <a:solidFill>
                   <a:schemeClr val="dk2"/>
@@ -5664,7 +5664,7 @@
                 <a:tab algn="l" pos="0"/>
               </a:tabLst>
             </a:pPr>
-            <a:fld id="{461C453A-CD1B-4EAF-B875-804112D0D4C9}" type="slidenum">
+            <a:fld id="{C289765B-2559-4E32-80BC-B9580DDACBA6}" type="slidenum">
               <a:rPr b="0" lang="en" sz="1000" strike="noStrike" u="none">
                 <a:solidFill>
                   <a:schemeClr val="dk2"/>
@@ -5832,7 +5832,7 @@
                 <a:tab algn="l" pos="0"/>
               </a:tabLst>
             </a:pPr>
-            <a:fld id="{8CC746D1-0E06-43D3-A140-7C1D58029AF4}" type="slidenum">
+            <a:fld id="{A8F72EC7-1A58-410E-850E-AE85E9914DFE}" type="slidenum">
               <a:rPr b="0" lang="en" sz="1000" strike="noStrike" u="none">
                 <a:solidFill>
                   <a:schemeClr val="dk2"/>
@@ -5941,7 +5941,7 @@
                 <a:tab algn="l" pos="0"/>
               </a:tabLst>
             </a:pPr>
-            <a:fld id="{5A895D5F-47CE-40A4-A997-3DB8133A1729}" type="slidenum">
+            <a:fld id="{B0F45FE5-D3FA-4194-AC50-1B280A692851}" type="slidenum">
               <a:rPr b="0" lang="en" sz="1000" strike="noStrike" u="none">
                 <a:solidFill>
                   <a:schemeClr val="dk2"/>
@@ -6931,7 +6931,7 @@
                 <a:tab algn="l" pos="0"/>
               </a:tabLst>
             </a:pPr>
-            <a:fld id="{1D4C2DB6-ADED-4B7F-83EA-9596A9A157B2}" type="slidenum">
+            <a:fld id="{820CA37F-AD64-4F0C-9C55-15A142C67000}" type="slidenum">
               <a:rPr b="0" lang="en" sz="1000" strike="noStrike" u="none">
                 <a:solidFill>
                   <a:schemeClr val="dk2"/>
@@ -7099,7 +7099,7 @@
                 <a:tab algn="l" pos="0"/>
               </a:tabLst>
             </a:pPr>
-            <a:fld id="{D37C0C11-389D-403E-A750-9AE85F1A0F17}" type="slidenum">
+            <a:fld id="{45DB7D2F-AABB-4374-B455-A8D2BF0590FF}" type="slidenum">
               <a:rPr b="0" lang="en" sz="1000" strike="noStrike" u="none">
                 <a:solidFill>
                   <a:schemeClr val="dk2"/>
@@ -7109,7 +7109,7 @@
                 <a:latin typeface="Arial"/>
                 <a:ea typeface="Arial"/>
               </a:rPr>
-              <a:t>&lt;número&gt;</a:t>
+              <a:t>6</a:t>
             </a:fld>
             <a:endParaRPr b="0" lang="es-MX" sz="1000" strike="noStrike" u="none">
               <a:solidFill>
@@ -8089,7 +8089,7 @@
                 <a:tab algn="l" pos="0"/>
               </a:tabLst>
             </a:pPr>
-            <a:fld id="{5A584D6C-B4AD-4F67-A884-75F240EDEB5F}" type="slidenum">
+            <a:fld id="{A0207A5D-DC8C-4FE7-B887-C75DD36CB811}" type="slidenum">
               <a:rPr b="0" lang="en" sz="1000" strike="noStrike" u="none">
                 <a:solidFill>
                   <a:schemeClr val="dk2"/>
@@ -9079,7 +9079,7 @@
                 <a:tab algn="l" pos="0"/>
               </a:tabLst>
             </a:pPr>
-            <a:fld id="{1451A95D-8909-4A8A-984F-18D5CDB037D5}" type="slidenum">
+            <a:fld id="{1A80BD33-CE57-4CB5-B103-DC18E992176B}" type="slidenum">
               <a:rPr b="0" lang="en" sz="1000" strike="noStrike" u="none">
                 <a:solidFill>
                   <a:schemeClr val="dk2"/>
@@ -9795,7 +9795,7 @@
                 <a:tab algn="l" pos="0"/>
               </a:tabLst>
             </a:pPr>
-            <a:fld id="{6A4FB1E7-CF6B-43B4-B394-A31C11961537}" type="slidenum">
+            <a:fld id="{4AB18852-76FC-4F44-B530-F2F9C6CD91C5}" type="slidenum">
               <a:rPr b="0" lang="en" sz="1000" strike="noStrike" u="none">
                 <a:solidFill>
                   <a:schemeClr val="dk2"/>
@@ -11059,7 +11059,7 @@
                 <a:tab algn="l" pos="0"/>
               </a:tabLst>
             </a:pPr>
-            <a:fld id="{97D1009E-C01C-48C3-898F-3A4D9B36F158}" type="slidenum">
+            <a:fld id="{28285949-BD7E-4813-8FEC-4859FF3937C1}" type="slidenum">
               <a:rPr b="0" lang="en" sz="1000" strike="noStrike" u="none">
                 <a:solidFill>
                   <a:schemeClr val="dk2"/>
@@ -12871,7 +12871,7 @@
                 <a:tab algn="l" pos="0"/>
               </a:tabLst>
             </a:pPr>
-            <a:fld id="{C2271AB6-3D70-4BEC-A23C-89AA2C20E893}" type="slidenum">
+            <a:fld id="{A01B609C-35C8-48FC-A579-89D7EEE2F515}" type="slidenum">
               <a:rPr b="0" lang="en" sz="1000" strike="noStrike" u="none">
                 <a:solidFill>
                   <a:schemeClr val="dk2"/>
@@ -12930,7 +12930,7 @@
         <p:txBody>
           <a:bodyPr/>
           <a:p>
-            <a:fld id="{4702D9A1-3B92-4468-ADF6-0B1FF0E65DCA}" type="slidenum">
+            <a:fld id="{BB214871-6D37-422B-8449-E10F09F0A692}" type="slidenum">
               <a:t>&lt;#&gt;</a:t>
             </a:fld>
           </a:p>
@@ -12972,7 +12972,7 @@
         <p:txBody>
           <a:bodyPr/>
           <a:p>
-            <a:fld id="{8C3D75AE-1A9D-47D8-A336-0BCA5B69E0F0}" type="slidenum">
+            <a:fld id="{8308052C-7AD5-416F-A418-D5EF69C0DFF8}" type="slidenum">
               <a:t>&lt;#&gt;</a:t>
             </a:fld>
           </a:p>
@@ -13397,7 +13397,7 @@
                 <a:tab algn="l" pos="0"/>
               </a:tabLst>
             </a:pPr>
-            <a:fld id="{0E378D2A-3DF9-4B56-811B-8DB8FADCF095}" type="slidenum">
+            <a:fld id="{A3CD1ADC-B922-40AD-AE9D-E472BC056757}" type="slidenum">
               <a:rPr b="0" lang="en" sz="1000" strike="noStrike" u="none">
                 <a:solidFill>
                   <a:schemeClr val="dk2"/>
@@ -14113,7 +14113,7 @@
                 <a:tab algn="l" pos="0"/>
               </a:tabLst>
             </a:pPr>
-            <a:fld id="{0071B1CF-4C70-486D-BB9B-EF098439C80C}" type="slidenum">
+            <a:fld id="{06DA8448-B019-4807-884C-08373E6E4EAA}" type="slidenum">
               <a:rPr b="0" lang="en" sz="1000" strike="noStrike" u="none">
                 <a:solidFill>
                   <a:schemeClr val="dk2"/>
@@ -14281,7 +14281,7 @@
                 <a:tab algn="l" pos="0"/>
               </a:tabLst>
             </a:pPr>
-            <a:fld id="{63644B59-D8BE-4F7B-9EA2-8596B47AC29F}" type="slidenum">
+            <a:fld id="{260DAC3A-7438-432C-8164-29ED5D53E578}" type="slidenum">
               <a:rPr b="0" lang="en" sz="1000" strike="noStrike" u="none">
                 <a:solidFill>
                   <a:schemeClr val="dk2"/>
@@ -14390,7 +14390,7 @@
                 <a:tab algn="l" pos="0"/>
               </a:tabLst>
             </a:pPr>
-            <a:fld id="{0A99155A-CA1D-4A50-8877-CED5D856BC6D}" type="slidenum">
+            <a:fld id="{9225BA0B-1EF9-4AB0-B856-5AACA2909306}" type="slidenum">
               <a:rPr b="0" lang="en" sz="1000" strike="noStrike" u="none">
                 <a:solidFill>
                   <a:schemeClr val="dk2"/>
@@ -15380,7 +15380,7 @@
                 <a:tab algn="l" pos="0"/>
               </a:tabLst>
             </a:pPr>
-            <a:fld id="{44F5F2E9-29F4-4849-8580-D65CA829D2E1}" type="slidenum">
+            <a:fld id="{AF384D8A-7021-449E-AC2F-AB986590A1B6}" type="slidenum">
               <a:rPr b="0" lang="en" sz="1000" strike="noStrike" u="none">
                 <a:solidFill>
                   <a:schemeClr val="dk2"/>
@@ -16370,7 +16370,7 @@
                 <a:tab algn="l" pos="0"/>
               </a:tabLst>
             </a:pPr>
-            <a:fld id="{DA96D5A5-D9CB-4C17-9659-D6D90DB44B6C}" type="slidenum">
+            <a:fld id="{CE9EA89E-3762-461A-9BAE-C185FC591B82}" type="slidenum">
               <a:rPr b="0" lang="en" sz="1000" strike="noStrike" u="none">
                 <a:solidFill>
                   <a:schemeClr val="dk2"/>
@@ -17360,7 +17360,7 @@
                 <a:tab algn="l" pos="0"/>
               </a:tabLst>
             </a:pPr>
-            <a:fld id="{CD276DC9-9AF6-42A9-B887-19A338695CF1}" type="slidenum">
+            <a:fld id="{704442DF-2B44-49C7-8EA2-0CC9D6886943}" type="slidenum">
               <a:rPr b="0" lang="en" sz="1000" strike="noStrike" u="none">
                 <a:solidFill>
                   <a:schemeClr val="dk2"/>
@@ -17543,7 +17543,7 @@
                 <a:tab algn="l" pos="0"/>
               </a:tabLst>
             </a:pPr>
-            <a:fld id="{BE77E0C6-F20C-424A-8F5F-837DFA07008C}" type="slidenum">
+            <a:fld id="{CF5AD391-F8CA-4743-A050-2428957DF688}" type="slidenum">
               <a:rPr b="0" lang="en" sz="1000" strike="noStrike" u="none">
                 <a:solidFill>
                   <a:schemeClr val="dk2"/>
@@ -17962,7 +17962,7 @@
                 <a:tab algn="l" pos="0"/>
               </a:tabLst>
             </a:pPr>
-            <a:fld id="{660E076C-2B86-4C52-9C6E-9AE0DD8FB5B0}" type="slidenum">
+            <a:fld id="{20A869D2-5CD4-4544-B47F-C51328E7FE46}" type="slidenum">
               <a:rPr b="0" lang="en" sz="1000" strike="noStrike" u="none">
                 <a:solidFill>
                   <a:schemeClr val="dk2"/>
@@ -18477,7 +18477,7 @@
                 <a:tab algn="l" pos="0"/>
               </a:tabLst>
             </a:pPr>
-            <a:fld id="{C34281A6-66F0-4DA2-9A61-28DBAE3CB309}" type="datetime5">
+            <a:fld id="{907C1685-AB39-4FA6-BB41-FF6B8E553FAB}" type="datetime5">
               <a:rPr b="0" lang="en" sz="1200" strike="noStrike" u="none">
                 <a:solidFill>
                   <a:srgbClr val="2a2a2a"/>
@@ -18790,7 +18790,7 @@
         <p:spPr>
           <a:xfrm>
             <a:off x="288000" y="1944000"/>
-            <a:ext cx="1979280" cy="2793960"/>
+            <a:ext cx="1979280" cy="2683800"/>
           </a:xfrm>
           <a:prstGeom prst="rect">
             <a:avLst/>
@@ -18863,24 +18863,9 @@
                 <a:uFillTx/>
                 <a:latin typeface="Arial"/>
               </a:rPr>
-              <a:t>Emocionado con el tema de hoy, ya conoci un poco de él</a:t>
-            </a:r>
-            <a:endParaRPr b="0" lang="es-MX" sz="1800" strike="noStrike" u="none">
-              <a:solidFill>
-                <a:srgbClr val="000000"/>
-              </a:solidFill>
-              <a:effectLst/>
-              <a:uFillTx/>
-              <a:latin typeface="Arial"/>
-            </a:endParaRPr>
-          </a:p>
-          <a:p>
-            <a:pPr>
-              <a:lnSpc>
-                <a:spcPct val="100000"/>
-              </a:lnSpc>
-            </a:pPr>
-            <a:endParaRPr b="0" lang="es-MX" sz="1000" strike="noStrike" u="none">
+              <a:t>Emocionado con el tema de hoy, ya lo conocía</a:t>
+            </a:r>
+            <a:endParaRPr b="0" lang="es-MX" sz="1800" strike="noStrike" u="none">
               <a:solidFill>
                 <a:srgbClr val="000000"/>
               </a:solidFill>

</xml_diff>